<commit_message>
fixed all case studies, not cleaned
</commit_message>
<xml_diff>
--- a/figures/Figure3_case2.pptx
+++ b/figures/Figure3_case2.pptx
@@ -253,7 +253,7 @@
       <p15:sldGuideLst xmlns:p15="http://schemas.microsoft.com/office/powerpoint/2012/main"/>
     </p:ext>
     <p:ext uri="GoogleSlidesCustomDataVersion2">
-      <go:slidesCustomData xmlns="" xmlns:mc="http://schemas.openxmlformats.org/markup-compatibility/2006" xmlns:mv="urn:schemas-microsoft-com:mac:vml" xmlns:c="http://schemas.openxmlformats.org/drawingml/2006/chart" xmlns:dgm="http://schemas.openxmlformats.org/drawingml/2006/diagram" xmlns:o="urn:schemas-microsoft-com:office:office" xmlns:v="urn:schemas-microsoft-com:vml" xmlns:pvml="urn:schemas-microsoft-com:office:powerpoint" xmlns:com="http://schemas.openxmlformats.org/drawingml/2006/compatibility" xmlns:p14="http://schemas.microsoft.com/office/powerpoint/2010/main" xmlns:p15="http://schemas.microsoft.com/office/powerpoint/2012/main" xmlns:ahyp="http://schemas.microsoft.com/office/drawing/2018/hyperlinkcolor" xmlns:go="http://customooxmlschemas.google.com/" r:id="rId8" roundtripDataSignature="AMtx7mhfnrVQrRcpZDcEMkrk0w6Yo+xwwQ=="/>
+      <go:slidesCustomData xmlns:go="http://customooxmlschemas.google.com/" xmlns:ahyp="http://schemas.microsoft.com/office/drawing/2018/hyperlinkcolor" xmlns:p15="http://schemas.microsoft.com/office/powerpoint/2012/main" xmlns:p14="http://schemas.microsoft.com/office/powerpoint/2010/main" xmlns:com="http://schemas.openxmlformats.org/drawingml/2006/compatibility" xmlns:pvml="urn:schemas-microsoft-com:office:powerpoint" xmlns:v="urn:schemas-microsoft-com:vml" xmlns:o="urn:schemas-microsoft-com:office:office" xmlns:dgm="http://schemas.openxmlformats.org/drawingml/2006/diagram" xmlns:c="http://schemas.openxmlformats.org/drawingml/2006/chart" xmlns:mv="urn:schemas-microsoft-com:mac:vml" xmlns:mc="http://schemas.openxmlformats.org/markup-compatibility/2006" xmlns="" r:id="rId8" roundtripDataSignature="AMtx7mhfnrVQrRcpZDcEMkrk0w6Yo+xwwQ=="/>
     </p:ext>
   </p:extLst>
 </p:presentation>
@@ -13404,7 +13404,7 @@
         </p:blipFill>
         <p:spPr>
           <a:xfrm>
-            <a:off x="7013295" y="3616391"/>
+            <a:off x="7329174" y="3644979"/>
             <a:ext cx="7843210" cy="3526282"/>
           </a:xfrm>
           <a:prstGeom prst="rect">
@@ -13592,36 +13592,6 @@
           <a:xfrm>
             <a:off x="7293777" y="7298689"/>
             <a:ext cx="11134018" cy="2618302"/>
-          </a:xfrm>
-          <a:prstGeom prst="rect">
-            <a:avLst/>
-          </a:prstGeom>
-        </p:spPr>
-      </p:pic>
-      <p:pic>
-        <p:nvPicPr>
-          <p:cNvPr id="2" name="Picture 1">
-            <a:extLst>
-              <a:ext uri="{FF2B5EF4-FFF2-40B4-BE49-F238E27FC236}">
-                <a16:creationId xmlns:a16="http://schemas.microsoft.com/office/drawing/2014/main" id="{90EBCB16-AB46-685F-1538-FF6550C4CB1E}"/>
-              </a:ext>
-            </a:extLst>
-          </p:cNvPr>
-          <p:cNvPicPr>
-            <a:picLocks noChangeAspect="1"/>
-          </p:cNvPicPr>
-          <p:nvPr/>
-        </p:nvPicPr>
-        <p:blipFill>
-          <a:blip r:embed="rId12"/>
-          <a:stretch>
-            <a:fillRect/>
-          </a:stretch>
-        </p:blipFill>
-        <p:spPr>
-          <a:xfrm>
-            <a:off x="7165695" y="3768791"/>
-            <a:ext cx="7843210" cy="3526282"/>
           </a:xfrm>
           <a:prstGeom prst="rect">
             <a:avLst/>

</xml_diff>